<commit_message>
Phase 2 review pass: retention verification, softened wording, OCR method, limitations, restructured conclusion
</commit_message>
<xml_diff>
--- a/BTP-Reproduction/text-failure-study/BTP_TextFailure_Deck.pptx
+++ b/BTP-Reproduction/text-failure-study/BTP_TextFailure_Deck.pptx
@@ -15,9 +15,10 @@
     <p:sldId id="263" r:id="rId9"/>
     <p:sldId id="264" r:id="rId10"/>
     <p:sldId id="265" r:id="rId11"/>
+    <p:sldId id="266" r:id="rId12"/>
   </p:sldIdLst>
   <p:notesMasterIdLst>
-    <p:notesMasterId r:id="rId12"/>
+    <p:notesMasterId r:id="rId13"/>
   </p:notesMasterIdLst>
   <p:sldSz cx="12192000" cy="6858000"/>
   <p:notesSz cx="6858000" cy="12192000"/>
@@ -599,7 +600,7 @@
           <a:p>
             <a:r>
               <a:rPr lang="en-US" dirty="0"/>
-              <a:t>Where this points next. First, make pruning aware of text: find the text-dense regions and exclude them from the cut. Second, adapt pruning strength to the task, hard for photos with lots of redundancy, gentle for documents and charts. And check whether other vision-language models behave the same way. Everything is in the repository. Thank you.</a:t>
+              <a:t>Here is the whole story in plain terms. The failure is not bad token selection; BTP actually tries to keep text. The real issue is that text has no redundancy. A photo is full of repetition, so dropping most of it is fine, and that is exactly why AI2D held up. But writing is different: every character is unique, so losing three quarters of it destroys the words no matter which quarter you keep. This is not a bug you can patch out; it is the nature of aggressive pruning meeting content that cannot be compressed. The natural fix is to make pruning aware of where the text is.</a:t>
             </a:r>
             <a:endParaRPr lang="en-US" dirty="0"/>
           </a:p>
@@ -623,6 +624,94 @@
             <a:fld id="{F7021451-1387-4CA6-816F-3879F97B5CBC}" type="slidenum">
               <a:rPr lang="en-US"/>
               <a:t>10</a:t>
+            </a:fld>
+            <a:endParaRPr lang="en-US"/>
+          </a:p>
+        </p:txBody>
+      </p:sp>
+    </p:spTree>
+    <p:extLst>
+      <p:ext uri="{BB962C8B-B14F-4D97-AF65-F5344CB8AC3E}">
+        <p14:creationId xmlns:p14="http://schemas.microsoft.com/office/powerpoint/2010/main" val="1024086991"/>
+      </p:ext>
+    </p:extLst>
+  </p:cSld>
+  <p:clrMapOvr>
+    <a:masterClrMapping/>
+  </p:clrMapOvr>
+</p:notes>
+</file>
+
+<file path=ppt/notesSlides/notesSlide11.xml><?xml version="1.0" encoding="utf-8"?>
+<p:notes xmlns:a="http://schemas.openxmlformats.org/drawingml/2006/main" xmlns:r="http://schemas.openxmlformats.org/officeDocument/2006/relationships" xmlns:p="http://schemas.openxmlformats.org/presentationml/2006/main">
+  <p:cSld>
+    <p:spTree>
+      <p:nvGrpSpPr>
+        <p:cNvPr id="1" name=""/>
+        <p:cNvGrpSpPr/>
+        <p:nvPr/>
+      </p:nvGrpSpPr>
+      <p:grpSpPr>
+        <a:xfrm>
+          <a:off x="0" y="0"/>
+          <a:ext cx="0" cy="0"/>
+          <a:chOff x="0" y="0"/>
+          <a:chExt cx="0" cy="0"/>
+        </a:xfrm>
+      </p:grpSpPr>
+      <p:sp>
+        <p:nvSpPr>
+          <p:cNvPr id="2" name="Slide Image Placeholder 1"/>
+          <p:cNvSpPr>
+            <a:spLocks noGrp="1" noRot="1" noChangeAspect="1"/>
+          </p:cNvSpPr>
+          <p:nvPr>
+            <p:ph type="sldImg"/>
+          </p:nvPr>
+        </p:nvSpPr>
+        <p:spPr/>
+      </p:sp>
+      <p:sp>
+        <p:nvSpPr>
+          <p:cNvPr id="3" name="Notes Placeholder 2"/>
+          <p:cNvSpPr>
+            <a:spLocks noGrp="1"/>
+          </p:cNvSpPr>
+          <p:nvPr>
+            <p:ph type="body" idx="1"/>
+          </p:nvPr>
+        </p:nvSpPr>
+        <p:spPr/>
+        <p:txBody>
+          <a:bodyPr/>
+          <a:lstStyle/>
+          <a:p>
+            <a:r>
+              <a:rPr lang="en-US" dirty="0"/>
+              <a:t>Where this points next. First, make pruning aware of text: find the text-dense regions and simply exclude them from the cut. Second, adapt the pruning strength to the task, hard for photos where there is lots of redundancy, gentle for documents and charts where there is not. And it is worth checking whether other vision-language models behave the same way. Everything is in the repository. Thank you.</a:t>
+            </a:r>
+            <a:endParaRPr lang="en-US" dirty="0"/>
+          </a:p>
+        </p:txBody>
+      </p:sp>
+      <p:sp>
+        <p:nvSpPr>
+          <p:cNvPr id="4" name="Slide Number Placeholder 3"/>
+          <p:cNvSpPr>
+            <a:spLocks noGrp="1"/>
+          </p:cNvSpPr>
+          <p:nvPr>
+            <p:ph type="sldNum" sz="quarter" idx="10"/>
+          </p:nvPr>
+        </p:nvSpPr>
+        <p:spPr/>
+        <p:txBody>
+          <a:bodyPr/>
+          <a:lstStyle/>
+          <a:p>
+            <a:fld id="{F7021451-1387-4CA6-816F-3879F97B5CBC}" type="slidenum">
+              <a:rPr lang="en-US"/>
+              <a:t>11</a:t>
             </a:fld>
             <a:endParaRPr lang="en-US"/>
           </a:p>
@@ -1303,7 +1392,7 @@
           <a:p>
             <a:r>
               <a:rPr lang="en-US" dirty="0"/>
-              <a:t>Here is the whole story in plain terms. The failure is not bad token selection; BTP actually tries to keep text. The real issue is that text has no redundancy. A photo is full of repetition, so dropping most of it is fine, and that is exactly why AI2D held up. But writing is different: every character is unique, so losing three quarters of it destroys the words no matter which quarter you keep. This is not a bug you can patch out; it is the nature of aggressive pruning meeting content that cannot be compressed. The natural fix is to make pruning aware of where the text is.</a:t>
+              <a:t>Being upfront about the limits: one model, a few benchmarks on subsets, a small qualitative visualization, and no direct intervention yet. Besides low redundancy, the collapse could also come from the pruning operation disrupting spatial or positional structure. These stay open.</a:t>
             </a:r>
             <a:endParaRPr lang="en-US" dirty="0"/>
           </a:p>
@@ -2667,6 +2756,343 @@
     <p:bg>
       <p:bgPr>
         <a:solidFill>
+          <a:srgbClr val="0B1F3A"/>
+        </a:solidFill>
+      </p:bgPr>
+    </p:bg>
+    <p:spTree>
+      <p:nvGrpSpPr>
+        <p:cNvPr id="1" name=""/>
+        <p:cNvGrpSpPr/>
+        <p:nvPr/>
+      </p:nvGrpSpPr>
+      <p:grpSpPr>
+        <a:xfrm>
+          <a:off x="0" y="0"/>
+          <a:ext cx="0" cy="0"/>
+          <a:chOff x="0" y="0"/>
+          <a:chExt cx="0" cy="0"/>
+        </a:xfrm>
+      </p:grpSpPr>
+      <p:sp>
+        <p:nvSpPr>
+          <p:cNvPr id="2" name="Shape 0"/>
+          <p:cNvSpPr/>
+          <p:nvPr/>
+        </p:nvSpPr>
+        <p:spPr>
+          <a:xfrm>
+            <a:off x="0" y="0"/>
+            <a:ext cx="12188952" cy="54864"/>
+          </a:xfrm>
+          <a:prstGeom prst="rect">
+            <a:avLst/>
+          </a:prstGeom>
+          <a:solidFill>
+            <a:srgbClr val="29C7AC"/>
+          </a:solidFill>
+          <a:ln/>
+        </p:spPr>
+      </p:sp>
+      <p:sp>
+        <p:nvSpPr>
+          <p:cNvPr id="3" name="Text 1"/>
+          <p:cNvSpPr/>
+          <p:nvPr/>
+        </p:nvSpPr>
+        <p:spPr>
+          <a:xfrm>
+            <a:off x="548640" y="457200"/>
+            <a:ext cx="7315200" cy="320040"/>
+          </a:xfrm>
+          <a:prstGeom prst="rect">
+            <a:avLst/>
+          </a:prstGeom>
+          <a:noFill/>
+          <a:ln/>
+        </p:spPr>
+        <p:txBody>
+          <a:bodyPr wrap="square" rtlCol="0" anchor="ctr"/>
+          <a:lstStyle/>
+          <a:p>
+            <a:pPr indent="0" marL="0">
+              <a:buNone/>
+            </a:pPr>
+            <a:r>
+              <a:rPr lang="en-US" sz="1200" b="1" spc="300" kern="0" dirty="0">
+                <a:solidFill>
+                  <a:srgbClr val="29C7AC"/>
+                </a:solidFill>
+                <a:latin typeface="Calibri" pitchFamily="34" charset="0"/>
+                <a:ea typeface="Calibri" pitchFamily="34" charset="-122"/>
+                <a:cs typeface="Calibri" pitchFamily="34" charset="-120"/>
+              </a:rPr>
+              <a:t>CONCLUSION</a:t>
+            </a:r>
+            <a:endParaRPr lang="en-US" sz="1200" dirty="0"/>
+          </a:p>
+        </p:txBody>
+      </p:sp>
+      <p:sp>
+        <p:nvSpPr>
+          <p:cNvPr id="4" name="Text 2"/>
+          <p:cNvSpPr/>
+          <p:nvPr/>
+        </p:nvSpPr>
+        <p:spPr>
+          <a:xfrm>
+            <a:off x="548640" y="777240"/>
+            <a:ext cx="11155680" cy="822960"/>
+          </a:xfrm>
+          <a:prstGeom prst="rect">
+            <a:avLst/>
+          </a:prstGeom>
+          <a:noFill/>
+          <a:ln/>
+        </p:spPr>
+        <p:txBody>
+          <a:bodyPr wrap="square" rtlCol="0" anchor="ctr"/>
+          <a:lstStyle/>
+          <a:p>
+            <a:pPr indent="0" marL="0">
+              <a:buNone/>
+            </a:pPr>
+            <a:r>
+              <a:rPr lang="en-US" sz="2300" b="1" dirty="0">
+                <a:solidFill>
+                  <a:srgbClr val="FFFFFF"/>
+                </a:solidFill>
+                <a:latin typeface="Georgia" pitchFamily="34" charset="0"/>
+                <a:ea typeface="Georgia" pitchFamily="34" charset="-122"/>
+                <a:cs typeface="Georgia" pitchFamily="34" charset="-120"/>
+              </a:rPr>
+              <a:t>Likely Not the Pruning Itself, but the Text</a:t>
+            </a:r>
+            <a:endParaRPr lang="en-US" sz="2300" dirty="0"/>
+          </a:p>
+        </p:txBody>
+      </p:sp>
+      <p:sp>
+        <p:nvSpPr>
+          <p:cNvPr id="5" name="Shape 3"/>
+          <p:cNvSpPr/>
+          <p:nvPr/>
+        </p:nvSpPr>
+        <p:spPr>
+          <a:xfrm>
+            <a:off x="914400" y="1783080"/>
+            <a:ext cx="10332720" cy="1600200"/>
+          </a:xfrm>
+          <a:prstGeom prst="roundRect">
+            <a:avLst>
+              <a:gd name="adj" fmla="val 4571"/>
+            </a:avLst>
+          </a:prstGeom>
+          <a:solidFill>
+            <a:srgbClr val="FFFFFF"/>
+          </a:solidFill>
+          <a:ln w="12700">
+            <a:solidFill>
+              <a:srgbClr val="E3EAF2"/>
+            </a:solidFill>
+            <a:prstDash val="solid"/>
+          </a:ln>
+          <a:effectLst>
+            <a:outerShdw sx="100000" sy="100000" kx="0" ky="0" algn="bl" rotWithShape="0" blurRad="88900" dist="38100" dir="8100000">
+              <a:srgbClr val="000000">
+                <a:alpha val="18000"/>
+              </a:srgbClr>
+            </a:outerShdw>
+          </a:effectLst>
+        </p:spPr>
+      </p:sp>
+      <p:sp>
+        <p:nvSpPr>
+          <p:cNvPr id="6" name="Text 4"/>
+          <p:cNvSpPr/>
+          <p:nvPr/>
+        </p:nvSpPr>
+        <p:spPr>
+          <a:xfrm>
+            <a:off x="1234440" y="1783080"/>
+            <a:ext cx="9692640" cy="1600200"/>
+          </a:xfrm>
+          <a:prstGeom prst="rect">
+            <a:avLst/>
+          </a:prstGeom>
+          <a:noFill/>
+          <a:ln/>
+        </p:spPr>
+        <p:txBody>
+          <a:bodyPr wrap="square" rtlCol="0" anchor="ctr"/>
+          <a:lstStyle/>
+          <a:p>
+            <a:pPr indent="0" marL="0">
+              <a:buNone/>
+            </a:pPr>
+            <a:r>
+              <a:rPr lang="en-US" sz="1650" dirty="0">
+                <a:solidFill>
+                  <a:srgbClr val="16222E"/>
+                </a:solidFill>
+                <a:latin typeface="Calibri" pitchFamily="34" charset="0"/>
+                <a:ea typeface="Calibri" pitchFamily="34" charset="-122"/>
+                <a:cs typeface="Calibri" pitchFamily="34" charset="-120"/>
+              </a:rPr>
+              <a:t>In a photo, one patch of sky looks like the next, so tossing most of them out costs you nothing. </a:t>
+            </a:r>
+            <a:pPr indent="0" marL="0">
+              <a:buNone/>
+            </a:pPr>
+            <a:r>
+              <a:rPr lang="en-US" sz="1650" b="1" dirty="0">
+                <a:solidFill>
+                  <a:srgbClr val="C0392B"/>
+                </a:solidFill>
+                <a:latin typeface="Calibri" pitchFamily="34" charset="0"/>
+                <a:ea typeface="Calibri" pitchFamily="34" charset="-122"/>
+                <a:cs typeface="Calibri" pitchFamily="34" charset="-120"/>
+              </a:rPr>
+              <a:t>But every letter on a page is its own thing. </a:t>
+            </a:r>
+            <a:pPr indent="0" marL="0">
+              <a:buNone/>
+            </a:pPr>
+            <a:r>
+              <a:rPr lang="en-US" sz="1650" dirty="0">
+                <a:solidFill>
+                  <a:srgbClr val="16222E"/>
+                </a:solidFill>
+                <a:latin typeface="Calibri" pitchFamily="34" charset="0"/>
+                <a:ea typeface="Calibri" pitchFamily="34" charset="-122"/>
+                <a:cs typeface="Calibri" pitchFamily="34" charset="-120"/>
+              </a:rPr>
+              <a:t>Keep only an eighth of the patches and the words simply fall apart, no matter how carefully you chose which ones to keep.</a:t>
+            </a:r>
+            <a:endParaRPr lang="en-US" sz="1650" dirty="0"/>
+          </a:p>
+        </p:txBody>
+      </p:sp>
+      <p:sp>
+        <p:nvSpPr>
+          <p:cNvPr id="7" name="Text 5"/>
+          <p:cNvSpPr/>
+          <p:nvPr/>
+        </p:nvSpPr>
+        <p:spPr>
+          <a:xfrm>
+            <a:off x="914400" y="3703320"/>
+            <a:ext cx="10332720" cy="4937760"/>
+          </a:xfrm>
+          <a:prstGeom prst="rect">
+            <a:avLst/>
+          </a:prstGeom>
+          <a:noFill/>
+          <a:ln/>
+        </p:spPr>
+        <p:txBody>
+          <a:bodyPr wrap="square" rtlCol="0" anchor="t"/>
+          <a:lstStyle/>
+          <a:p>
+            <a:pPr marL="228600" indent="-228600">
+              <a:spcAft>
+                <a:spcPts val="900"/>
+              </a:spcAft>
+              <a:buSzPct val="100000"/>
+              <a:buChar char="•"/>
+            </a:pPr>
+            <a:r>
+              <a:rPr lang="en-US" sz="1500" dirty="0">
+                <a:solidFill>
+                  <a:srgbClr val="FFFFFF"/>
+                </a:solidFill>
+                <a:latin typeface="Calibri" pitchFamily="34" charset="0"/>
+                <a:ea typeface="Calibri" pitchFamily="34" charset="-122"/>
+                <a:cs typeface="Calibri" pitchFamily="34" charset="-120"/>
+              </a:rPr>
+              <a:t>BTP is actually smart about it: it spots text and tries to hold on to it</a:t>
+            </a:r>
+            <a:endParaRPr lang="en-US" sz="1500" dirty="0"/>
+          </a:p>
+          <a:p>
+            <a:pPr marL="228600" indent="-228600">
+              <a:spcAft>
+                <a:spcPts val="900"/>
+              </a:spcAft>
+              <a:buSzPct val="100000"/>
+              <a:buChar char="•"/>
+            </a:pPr>
+            <a:r>
+              <a:rPr lang="en-US" sz="1500" dirty="0">
+                <a:solidFill>
+                  <a:srgbClr val="FFFFFF"/>
+                </a:solidFill>
+                <a:latin typeface="Calibri" pitchFamily="34" charset="0"/>
+                <a:ea typeface="Calibri" pitchFamily="34" charset="-122"/>
+                <a:cs typeface="Calibri" pitchFamily="34" charset="-120"/>
+              </a:rPr>
+              <a:t>But text has no spare copies; every stroke carries meaning you cannot get back</a:t>
+            </a:r>
+            <a:endParaRPr lang="en-US" sz="1500" dirty="0"/>
+          </a:p>
+          <a:p>
+            <a:pPr marL="228600" indent="-228600">
+              <a:spcAft>
+                <a:spcPts val="900"/>
+              </a:spcAft>
+              <a:buSzPct val="100000"/>
+              <a:buChar char="•"/>
+            </a:pPr>
+            <a:r>
+              <a:rPr lang="en-US" sz="1500" dirty="0">
+                <a:solidFill>
+                  <a:srgbClr val="FFFFFF"/>
+                </a:solidFill>
+                <a:latin typeface="Calibri" pitchFamily="34" charset="0"/>
+                <a:ea typeface="Calibri" pitchFamily="34" charset="-122"/>
+                <a:cs typeface="Calibri" pitchFamily="34" charset="-120"/>
+              </a:rPr>
+              <a:t>Photos and diagrams are full of repetition, so they survive the cut. That is why AI2D barely flinched</a:t>
+            </a:r>
+            <a:endParaRPr lang="en-US" sz="1500" dirty="0"/>
+          </a:p>
+          <a:p>
+            <a:pPr marL="228600" indent="-228600">
+              <a:spcAft>
+                <a:spcPts val="900"/>
+              </a:spcAft>
+              <a:buSzPct val="100000"/>
+              <a:buChar char="•"/>
+            </a:pPr>
+            <a:r>
+              <a:rPr lang="en-US" sz="1500" b="1" dirty="0">
+                <a:solidFill>
+                  <a:srgbClr val="29C7AC"/>
+                </a:solidFill>
+                <a:latin typeface="Calibri" pitchFamily="34" charset="0"/>
+                <a:ea typeface="Calibri" pitchFamily="34" charset="-122"/>
+                <a:cs typeface="Calibri" pitchFamily="34" charset="-120"/>
+              </a:rPr>
+              <a:t>So our leading explanation is not a flaw in the selection, but the nature of squeezing content with little to spare (a hypothesis, not proof).</a:t>
+            </a:r>
+            <a:endParaRPr lang="en-US" sz="1500" dirty="0"/>
+          </a:p>
+        </p:txBody>
+      </p:sp>
+    </p:spTree>
+  </p:cSld>
+  <p:clrMapOvr>
+    <a:masterClrMapping/>
+  </p:clrMapOvr>
+</p:sld>
+</file>
+
+<file path=ppt/slides/slide11.xml><?xml version="1.0" encoding="utf-8"?>
+<p:sld xmlns:a="http://schemas.openxmlformats.org/drawingml/2006/main" xmlns:r="http://schemas.openxmlformats.org/officeDocument/2006/relationships" xmlns:p="http://schemas.openxmlformats.org/presentationml/2006/main">
+  <p:cSld name="Slide 11">
+    <p:bg>
+      <p:bgPr>
+        <a:solidFill>
           <a:srgbClr val="F4F7FB"/>
         </a:solidFill>
       </p:bgPr>
@@ -3448,7 +3874,7 @@
                 <a:ea typeface="Calibri" pitchFamily="34" charset="-122"/>
                 <a:cs typeface="Calibri" pitchFamily="34" charset="-120"/>
               </a:rPr>
-              <a:t>6</a:t>
+              <a:t>7</a:t>
             </a:r>
             <a:endParaRPr lang="en-US" sz="1000" dirty="0"/>
           </a:p>
@@ -6525,7 +6951,7 @@
                 <a:ea typeface="Calibri" pitchFamily="34" charset="-122"/>
                 <a:cs typeface="Calibri" pitchFamily="34" charset="-120"/>
               </a:rPr>
-              <a:t>Every text-heavy task falls apart (down 48 to 76 points). </a:t>
+              <a:t>All the text-heavy tasks we tested degrade sharply (down 48 to 76 points). </a:t>
             </a:r>
             <a:pPr indent="0" marL="0">
               <a:buNone/>
@@ -6539,7 +6965,7 @@
                 <a:ea typeface="Calibri" pitchFamily="34" charset="-122"/>
                 <a:cs typeface="Calibri" pitchFamily="34" charset="-120"/>
               </a:rPr>
-              <a:t>The one that holds up is AI2D, which reads diagram layout more than dense text. That contrast is the tell: the problem is specifically about reading text, not vision in general.</a:t>
+              <a:t>AI2D, which leans on diagram layout, holds up. The contrast is consistent with the failure being about dense text, though AI2D alone does not prove it is the only cause.</a:t>
             </a:r>
             <a:endParaRPr lang="en-US" sz="1400" dirty="0"/>
           </a:p>
@@ -7810,7 +8236,7 @@
     <p:bg>
       <p:bgPr>
         <a:solidFill>
-          <a:srgbClr val="0B1F3A"/>
+          <a:srgbClr val="F4F7FB"/>
         </a:solidFill>
       </p:bgPr>
     </p:bg>
@@ -7837,6 +8263,26 @@
         <p:spPr>
           <a:xfrm>
             <a:off x="0" y="0"/>
+            <a:ext cx="12188952" cy="1051560"/>
+          </a:xfrm>
+          <a:prstGeom prst="rect">
+            <a:avLst/>
+          </a:prstGeom>
+          <a:solidFill>
+            <a:srgbClr val="0B1F3A"/>
+          </a:solidFill>
+          <a:ln/>
+        </p:spPr>
+      </p:sp>
+      <p:sp>
+        <p:nvSpPr>
+          <p:cNvPr id="3" name="Shape 1"/>
+          <p:cNvSpPr/>
+          <p:nvPr/>
+        </p:nvSpPr>
+        <p:spPr>
+          <a:xfrm>
+            <a:off x="0" y="1051560"/>
             <a:ext cx="12188952" cy="54864"/>
           </a:xfrm>
           <a:prstGeom prst="rect">
@@ -7850,14 +8296,14 @@
       </p:sp>
       <p:sp>
         <p:nvSpPr>
-          <p:cNvPr id="3" name="Text 1"/>
-          <p:cNvSpPr/>
-          <p:nvPr/>
-        </p:nvSpPr>
-        <p:spPr>
-          <a:xfrm>
-            <a:off x="548640" y="457200"/>
-            <a:ext cx="7315200" cy="320040"/>
+          <p:cNvPr id="4" name="Text 2"/>
+          <p:cNvSpPr/>
+          <p:nvPr/>
+        </p:nvSpPr>
+        <p:spPr>
+          <a:xfrm>
+            <a:off x="548640" y="164592"/>
+            <a:ext cx="10972800" cy="274320"/>
           </a:xfrm>
           <a:prstGeom prst="rect">
             <a:avLst/>
@@ -7873,7 +8319,7 @@
               <a:buNone/>
             </a:pPr>
             <a:r>
-              <a:rPr lang="en-US" sz="1200" b="1" spc="300" kern="0" dirty="0">
+              <a:rPr lang="en-US" sz="1100" b="1" spc="300" kern="0" dirty="0">
                 <a:solidFill>
                   <a:srgbClr val="29C7AC"/>
                 </a:solidFill>
@@ -7881,22 +8327,22 @@
                 <a:ea typeface="Calibri" pitchFamily="34" charset="-122"/>
                 <a:cs typeface="Calibri" pitchFamily="34" charset="-120"/>
               </a:rPr>
-              <a:t>CONCLUSION</a:t>
-            </a:r>
-            <a:endParaRPr lang="en-US" sz="1200" dirty="0"/>
-          </a:p>
-        </p:txBody>
-      </p:sp>
-      <p:sp>
-        <p:nvSpPr>
-          <p:cNvPr id="4" name="Text 2"/>
-          <p:cNvSpPr/>
-          <p:nvPr/>
-        </p:nvSpPr>
-        <p:spPr>
-          <a:xfrm>
-            <a:off x="548640" y="777240"/>
-            <a:ext cx="11155680" cy="822960"/>
+              <a:t>CAVEATS</a:t>
+            </a:r>
+            <a:endParaRPr lang="en-US" sz="1100" dirty="0"/>
+          </a:p>
+        </p:txBody>
+      </p:sp>
+      <p:sp>
+        <p:nvSpPr>
+          <p:cNvPr id="5" name="Text 3"/>
+          <p:cNvSpPr/>
+          <p:nvPr/>
+        </p:nvSpPr>
+        <p:spPr>
+          <a:xfrm>
+            <a:off x="548640" y="384048"/>
+            <a:ext cx="11064240" cy="603504"/>
           </a:xfrm>
           <a:prstGeom prst="rect">
             <a:avLst/>
@@ -7912,7 +8358,7 @@
               <a:buNone/>
             </a:pPr>
             <a:r>
-              <a:rPr lang="en-US" sz="2300" b="1" dirty="0">
+              <a:rPr lang="en-US" sz="2500" b="1" dirty="0">
                 <a:solidFill>
                   <a:srgbClr val="FFFFFF"/>
                 </a:solidFill>
@@ -7920,45 +8366,11 @@
                 <a:ea typeface="Georgia" pitchFamily="34" charset="-122"/>
                 <a:cs typeface="Georgia" pitchFamily="34" charset="-120"/>
               </a:rPr>
-              <a:t>The Problem Is Not the Pruning. Text Just Cannot Be Squeezed.</a:t>
-            </a:r>
-            <a:endParaRPr lang="en-US" sz="2300" dirty="0"/>
-          </a:p>
-        </p:txBody>
-      </p:sp>
-      <p:sp>
-        <p:nvSpPr>
-          <p:cNvPr id="5" name="Shape 3"/>
-          <p:cNvSpPr/>
-          <p:nvPr/>
-        </p:nvSpPr>
-        <p:spPr>
-          <a:xfrm>
-            <a:off x="914400" y="1783080"/>
-            <a:ext cx="10332720" cy="1600200"/>
-          </a:xfrm>
-          <a:prstGeom prst="roundRect">
-            <a:avLst>
-              <a:gd name="adj" fmla="val 4571"/>
-            </a:avLst>
-          </a:prstGeom>
-          <a:solidFill>
-            <a:srgbClr val="FFFFFF"/>
-          </a:solidFill>
-          <a:ln w="12700">
-            <a:solidFill>
-              <a:srgbClr val="E3EAF2"/>
-            </a:solidFill>
-            <a:prstDash val="solid"/>
-          </a:ln>
-          <a:effectLst>
-            <a:outerShdw sx="100000" sy="100000" kx="0" ky="0" algn="bl" rotWithShape="0" blurRad="88900" dist="38100" dir="8100000">
-              <a:srgbClr val="000000">
-                <a:alpha val="18000"/>
-              </a:srgbClr>
-            </a:outerShdw>
-          </a:effectLst>
-        </p:spPr>
+              <a:t>Limitations</a:t>
+            </a:r>
+            <a:endParaRPr lang="en-US" sz="2500" dirty="0"/>
+          </a:p>
+        </p:txBody>
       </p:sp>
       <p:sp>
         <p:nvSpPr>
@@ -7968,75 +8380,8 @@
         </p:nvSpPr>
         <p:spPr>
           <a:xfrm>
-            <a:off x="1234440" y="1783080"/>
-            <a:ext cx="9692640" cy="1600200"/>
-          </a:xfrm>
-          <a:prstGeom prst="rect">
-            <a:avLst/>
-          </a:prstGeom>
-          <a:noFill/>
-          <a:ln/>
-        </p:spPr>
-        <p:txBody>
-          <a:bodyPr wrap="square" rtlCol="0" anchor="ctr"/>
-          <a:lstStyle/>
-          <a:p>
-            <a:pPr indent="0" marL="0">
-              <a:buNone/>
-            </a:pPr>
-            <a:r>
-              <a:rPr lang="en-US" sz="1650" dirty="0">
-                <a:solidFill>
-                  <a:srgbClr val="16222E"/>
-                </a:solidFill>
-                <a:latin typeface="Calibri" pitchFamily="34" charset="0"/>
-                <a:ea typeface="Calibri" pitchFamily="34" charset="-122"/>
-                <a:cs typeface="Calibri" pitchFamily="34" charset="-120"/>
-              </a:rPr>
-              <a:t>In a photo, one patch of sky looks like the next, so tossing most of them out costs you nothing. </a:t>
-            </a:r>
-            <a:pPr indent="0" marL="0">
-              <a:buNone/>
-            </a:pPr>
-            <a:r>
-              <a:rPr lang="en-US" sz="1650" b="1" dirty="0">
-                <a:solidFill>
-                  <a:srgbClr val="C0392B"/>
-                </a:solidFill>
-                <a:latin typeface="Calibri" pitchFamily="34" charset="0"/>
-                <a:ea typeface="Calibri" pitchFamily="34" charset="-122"/>
-                <a:cs typeface="Calibri" pitchFamily="34" charset="-120"/>
-              </a:rPr>
-              <a:t>But every letter on a page is its own thing. </a:t>
-            </a:r>
-            <a:pPr indent="0" marL="0">
-              <a:buNone/>
-            </a:pPr>
-            <a:r>
-              <a:rPr lang="en-US" sz="1650" dirty="0">
-                <a:solidFill>
-                  <a:srgbClr val="16222E"/>
-                </a:solidFill>
-                <a:latin typeface="Calibri" pitchFamily="34" charset="0"/>
-                <a:ea typeface="Calibri" pitchFamily="34" charset="-122"/>
-                <a:cs typeface="Calibri" pitchFamily="34" charset="-120"/>
-              </a:rPr>
-              <a:t>Keep only an eighth of the patches and the words simply fall apart, no matter how carefully you chose which ones to keep.</a:t>
-            </a:r>
-            <a:endParaRPr lang="en-US" sz="1650" dirty="0"/>
-          </a:p>
-        </p:txBody>
-      </p:sp>
-      <p:sp>
-        <p:nvSpPr>
-          <p:cNvPr id="7" name="Text 5"/>
-          <p:cNvSpPr/>
-          <p:nvPr/>
-        </p:nvSpPr>
-        <p:spPr>
-          <a:xfrm>
-            <a:off x="914400" y="3703320"/>
-            <a:ext cx="10332720" cy="4937760"/>
+            <a:off x="822960" y="1600200"/>
+            <a:ext cx="10515600" cy="4937760"/>
           </a:xfrm>
           <a:prstGeom prst="rect">
             <a:avLst/>
@@ -8050,86 +8395,146 @@
           <a:p>
             <a:pPr marL="228600" indent="-228600">
               <a:spcAft>
-                <a:spcPts val="900"/>
+                <a:spcPts val="1300"/>
               </a:spcAft>
               <a:buSzPct val="100000"/>
               <a:buChar char="•"/>
             </a:pPr>
             <a:r>
-              <a:rPr lang="en-US" sz="1500" dirty="0">
-                <a:solidFill>
-                  <a:srgbClr val="FFFFFF"/>
-                </a:solidFill>
-                <a:latin typeface="Calibri" pitchFamily="34" charset="0"/>
-                <a:ea typeface="Calibri" pitchFamily="34" charset="-122"/>
-                <a:cs typeface="Calibri" pitchFamily="34" charset="-120"/>
-              </a:rPr>
-              <a:t>BTP is actually smart about it: it spots text and tries to hold on to it</a:t>
-            </a:r>
-            <a:endParaRPr lang="en-US" sz="1500" dirty="0"/>
+              <a:rPr lang="en-US" sz="1600" dirty="0">
+                <a:solidFill>
+                  <a:srgbClr val="16222E"/>
+                </a:solidFill>
+                <a:latin typeface="Calibri" pitchFamily="34" charset="0"/>
+                <a:ea typeface="Calibri" pitchFamily="34" charset="-122"/>
+                <a:cs typeface="Calibri" pitchFamily="34" charset="-120"/>
+              </a:rPr>
+              <a:t>Single model (Qwen2.5-VL-7B); not yet tested on other vision-language models</a:t>
+            </a:r>
+            <a:endParaRPr lang="en-US" sz="1600" dirty="0"/>
           </a:p>
           <a:p>
             <a:pPr marL="228600" indent="-228600">
               <a:spcAft>
-                <a:spcPts val="900"/>
+                <a:spcPts val="1300"/>
               </a:spcAft>
               <a:buSzPct val="100000"/>
               <a:buChar char="•"/>
             </a:pPr>
             <a:r>
-              <a:rPr lang="en-US" sz="1500" dirty="0">
-                <a:solidFill>
-                  <a:srgbClr val="FFFFFF"/>
-                </a:solidFill>
-                <a:latin typeface="Calibri" pitchFamily="34" charset="0"/>
-                <a:ea typeface="Calibri" pitchFamily="34" charset="-122"/>
-                <a:cs typeface="Calibri" pitchFamily="34" charset="-120"/>
-              </a:rPr>
-              <a:t>But text has no spare copies; every stroke carries meaning you cannot get back</a:t>
-            </a:r>
-            <a:endParaRPr lang="en-US" sz="1500" dirty="0"/>
+              <a:rPr lang="en-US" sz="1600" dirty="0">
+                <a:solidFill>
+                  <a:srgbClr val="16222E"/>
+                </a:solidFill>
+                <a:latin typeface="Calibri" pitchFamily="34" charset="0"/>
+                <a:ea typeface="Calibri" pitchFamily="34" charset="-122"/>
+                <a:cs typeface="Calibri" pitchFamily="34" charset="-120"/>
+              </a:rPr>
+              <a:t>Limited benchmark set, evaluated on reduced-size subsets</a:t>
+            </a:r>
+            <a:endParaRPr lang="en-US" sz="1600" dirty="0"/>
           </a:p>
           <a:p>
             <a:pPr marL="228600" indent="-228600">
               <a:spcAft>
-                <a:spcPts val="900"/>
+                <a:spcPts val="1300"/>
               </a:spcAft>
               <a:buSzPct val="100000"/>
               <a:buChar char="•"/>
             </a:pPr>
             <a:r>
-              <a:rPr lang="en-US" sz="1500" dirty="0">
-                <a:solidFill>
-                  <a:srgbClr val="FFFFFF"/>
-                </a:solidFill>
-                <a:latin typeface="Calibri" pitchFamily="34" charset="0"/>
-                <a:ea typeface="Calibri" pitchFamily="34" charset="-122"/>
-                <a:cs typeface="Calibri" pitchFamily="34" charset="-120"/>
-              </a:rPr>
-              <a:t>Photos and diagrams are full of repetition, so they survive the cut. That is why AI2D barely flinched</a:t>
-            </a:r>
-            <a:endParaRPr lang="en-US" sz="1500" dirty="0"/>
+              <a:rPr lang="en-US" sz="1600" dirty="0">
+                <a:solidFill>
+                  <a:srgbClr val="16222E"/>
+                </a:solidFill>
+                <a:latin typeface="Calibri" pitchFamily="34" charset="0"/>
+                <a:ea typeface="Calibri" pitchFamily="34" charset="-122"/>
+                <a:cs typeface="Calibri" pitchFamily="34" charset="-120"/>
+              </a:rPr>
+              <a:t>Token visualization is small-sample (12 images) and qualitative</a:t>
+            </a:r>
+            <a:endParaRPr lang="en-US" sz="1600" dirty="0"/>
           </a:p>
           <a:p>
             <a:pPr marL="228600" indent="-228600">
               <a:spcAft>
-                <a:spcPts val="900"/>
+                <a:spcPts val="1300"/>
               </a:spcAft>
               <a:buSzPct val="100000"/>
               <a:buChar char="•"/>
             </a:pPr>
             <a:r>
-              <a:rPr lang="en-US" sz="1500" b="1" dirty="0">
-                <a:solidFill>
-                  <a:srgbClr val="29C7AC"/>
-                </a:solidFill>
-                <a:latin typeface="Calibri" pitchFamily="34" charset="0"/>
-                <a:ea typeface="Calibri" pitchFamily="34" charset="-122"/>
-                <a:cs typeface="Calibri" pitchFamily="34" charset="-120"/>
-              </a:rPr>
-              <a:t>So this is not a bug to patch. It is what happens when you squeeze something that has nothing to spare.</a:t>
-            </a:r>
-            <a:endParaRPr lang="en-US" sz="1500" dirty="0"/>
+              <a:rPr lang="en-US" sz="1600" dirty="0">
+                <a:solidFill>
+                  <a:srgbClr val="16222E"/>
+                </a:solidFill>
+                <a:latin typeface="Calibri" pitchFamily="34" charset="0"/>
+                <a:ea typeface="Calibri" pitchFamily="34" charset="-122"/>
+                <a:cs typeface="Calibri" pitchFamily="34" charset="-120"/>
+              </a:rPr>
+              <a:t>No direct intervention yet to confirm the mechanism</a:t>
+            </a:r>
+            <a:endParaRPr lang="en-US" sz="1600" dirty="0"/>
+          </a:p>
+          <a:p>
+            <a:pPr marL="228600" indent="-228600">
+              <a:spcAft>
+                <a:spcPts val="1300"/>
+              </a:spcAft>
+              <a:buSzPct val="100000"/>
+              <a:buChar char="•"/>
+            </a:pPr>
+            <a:r>
+              <a:rPr lang="en-US" sz="1600" dirty="0">
+                <a:solidFill>
+                  <a:srgbClr val="16222E"/>
+                </a:solidFill>
+                <a:latin typeface="Calibri" pitchFamily="34" charset="0"/>
+                <a:ea typeface="Calibri" pitchFamily="34" charset="-122"/>
+                <a:cs typeface="Calibri" pitchFamily="34" charset="-120"/>
+              </a:rPr>
+              <a:t>Alternative causes remain open: pruning may disrupt spatial continuity or early text-feature formation</a:t>
+            </a:r>
+            <a:endParaRPr lang="en-US" sz="1600" dirty="0"/>
+          </a:p>
+        </p:txBody>
+      </p:sp>
+      <p:sp>
+        <p:nvSpPr>
+          <p:cNvPr id="7" name="Text 5"/>
+          <p:cNvSpPr/>
+          <p:nvPr/>
+        </p:nvSpPr>
+        <p:spPr>
+          <a:xfrm>
+            <a:off x="11612880" y="6400800"/>
+            <a:ext cx="457200" cy="274320"/>
+          </a:xfrm>
+          <a:prstGeom prst="rect">
+            <a:avLst/>
+          </a:prstGeom>
+          <a:noFill/>
+          <a:ln/>
+        </p:spPr>
+        <p:txBody>
+          <a:bodyPr wrap="square" rtlCol="0" anchor="ctr"/>
+          <a:lstStyle/>
+          <a:p>
+            <a:pPr algn="r" indent="0" marL="0">
+              <a:buNone/>
+            </a:pPr>
+            <a:r>
+              <a:rPr lang="en-US" sz="1000" dirty="0">
+                <a:solidFill>
+                  <a:srgbClr val="5A6B7B"/>
+                </a:solidFill>
+                <a:latin typeface="Calibri" pitchFamily="34" charset="0"/>
+                <a:ea typeface="Calibri" pitchFamily="34" charset="-122"/>
+                <a:cs typeface="Calibri" pitchFamily="34" charset="-120"/>
+              </a:rPr>
+              <a:t>6</a:t>
+            </a:r>
+            <a:endParaRPr lang="en-US" sz="1000" dirty="0"/>
           </a:p>
         </p:txBody>
       </p:sp>

</xml_diff>